<commit_message>
Update J2 book (15 slides) and synthesis (10 slides)
New content added:
- Slide 12: Bataille de Solférino — récit illustré, Henri Dunant,
  Tutti Fratelli, drapeau suisse inversé, Nobel 1901
- Slide 13: Comité de la Charte (1989/1996), CICR zones de conflit,
  Fidelis = RUP exclusivement, Particuliers vs Professionnels
- Slide 14: La Qualification — enjeu critique (50% qualité Fidelis),
  impact financier fausse qualification, 300-400K fiches/mois,
  tableau complet des codes, exemple erreur répondeur ≠ RA
- Slide 15: Nomenclature complémentaire — ABSENT, CICR, Comité
  de la Charte, Particulier/Professionnel
- Synthèse slide 10: quiz qualification + nomenclature complémentaire

https://claude.ai/code/session_017qsYoeojf57UYvTwdv5u93
</commit_message>
<xml_diff>
--- a/Synthese_J2_Matin_Fidelis.pptx
+++ b/Synthese_J2_Matin_Fidelis.pptx
@@ -14,6 +14,7 @@
     <p:sldId id="262" r:id="rId13"/>
     <p:sldId id="263" r:id="rId14"/>
     <p:sldId id="264" r:id="rId15"/>
+    <p:sldId id="265" r:id="rId16"/>
   </p:sldIdLst>
   <p:sldSz cx="12188952" cy="6858000" type="screen4x3"/>
   <p:notesSz cx="6858000" cy="9144000"/>
@@ -4369,6 +4370,2232 @@
                 <a:latin typeface="Segoe UI"/>
               </a:rPr>
               <a:t>08  Impact UNICEF — Chiffres vérifiables</a:t>
+            </a:r>
+          </a:p>
+        </p:txBody>
+      </p:sp>
+    </p:spTree>
+  </p:cSld>
+  <p:clrMapOvr>
+    <a:masterClrMapping/>
+  </p:clrMapOvr>
+</p:sld>
+</file>
+
+<file path=ppt/slides/slide10.xml><?xml version="1.0" encoding="utf-8"?>
+<p:sld xmlns:a="http://schemas.openxmlformats.org/drawingml/2006/main" xmlns:p="http://schemas.openxmlformats.org/presentationml/2006/main" xmlns:r="http://schemas.openxmlformats.org/officeDocument/2006/relationships">
+  <p:cSld>
+    <p:spTree>
+      <p:nvGrpSpPr>
+        <p:cNvPr id="1" name=""/>
+        <p:cNvGrpSpPr/>
+        <p:nvPr/>
+      </p:nvGrpSpPr>
+      <p:grpSpPr/>
+      <p:sp>
+        <p:nvSpPr>
+          <p:cNvPr id="2" name="Rectangle 1"/>
+          <p:cNvSpPr/>
+          <p:nvPr/>
+        </p:nvSpPr>
+        <p:spPr>
+          <a:xfrm>
+            <a:off x="0" y="0"/>
+            <a:ext cx="12188952" cy="1234440"/>
+          </a:xfrm>
+          <a:prstGeom prst="rect">
+            <a:avLst/>
+          </a:prstGeom>
+          <a:solidFill>
+            <a:srgbClr val="003087"/>
+          </a:solidFill>
+          <a:ln>
+            <a:noFill/>
+          </a:ln>
+        </p:spPr>
+        <p:style>
+          <a:lnRef idx="1">
+            <a:schemeClr val="accent1"/>
+          </a:lnRef>
+          <a:fillRef idx="3">
+            <a:schemeClr val="accent1"/>
+          </a:fillRef>
+          <a:effectRef idx="2">
+            <a:schemeClr val="accent1"/>
+          </a:effectRef>
+          <a:fontRef idx="minor">
+            <a:schemeClr val="lt1"/>
+          </a:fontRef>
+        </p:style>
+        <p:txBody>
+          <a:bodyPr rtlCol="0" anchor="ctr"/>
+          <a:lstStyle/>
+          <a:p>
+            <a:pPr algn="ctr"/>
+          </a:p>
+        </p:txBody>
+      </p:sp>
+      <p:sp>
+        <p:nvSpPr>
+          <p:cNvPr id="3" name="Rectangle 2"/>
+          <p:cNvSpPr/>
+          <p:nvPr/>
+        </p:nvSpPr>
+        <p:spPr>
+          <a:xfrm>
+            <a:off x="0" y="0"/>
+            <a:ext cx="12188952" cy="54864"/>
+          </a:xfrm>
+          <a:prstGeom prst="rect">
+            <a:avLst/>
+          </a:prstGeom>
+          <a:solidFill>
+            <a:srgbClr val="E74C3C"/>
+          </a:solidFill>
+          <a:ln>
+            <a:noFill/>
+          </a:ln>
+        </p:spPr>
+        <p:style>
+          <a:lnRef idx="1">
+            <a:schemeClr val="accent1"/>
+          </a:lnRef>
+          <a:fillRef idx="3">
+            <a:schemeClr val="accent1"/>
+          </a:fillRef>
+          <a:effectRef idx="2">
+            <a:schemeClr val="accent1"/>
+          </a:effectRef>
+          <a:fontRef idx="minor">
+            <a:schemeClr val="lt1"/>
+          </a:fontRef>
+        </p:style>
+        <p:txBody>
+          <a:bodyPr rtlCol="0" anchor="ctr"/>
+          <a:lstStyle/>
+          <a:p>
+            <a:pPr algn="ctr"/>
+          </a:p>
+        </p:txBody>
+      </p:sp>
+      <p:sp>
+        <p:nvSpPr>
+          <p:cNvPr id="4" name="TextBox 3"/>
+          <p:cNvSpPr txBox="1"/>
+          <p:nvPr/>
+        </p:nvSpPr>
+        <p:spPr>
+          <a:xfrm>
+            <a:off x="365760" y="91440"/>
+            <a:ext cx="11430000" cy="530352"/>
+          </a:xfrm>
+          <a:prstGeom prst="rect">
+            <a:avLst/>
+          </a:prstGeom>
+          <a:noFill/>
+        </p:spPr>
+        <p:txBody>
+          <a:bodyPr wrap="square">
+            <a:spAutoFit/>
+          </a:bodyPr>
+          <a:lstStyle/>
+          <a:p>
+            <a:pPr algn="l"/>
+            <a:r>
+              <a:rPr sz="2200" b="1" i="0">
+                <a:solidFill>
+                  <a:srgbClr val="FFFFFF"/>
+                </a:solidFill>
+                <a:latin typeface="Segoe UI"/>
+              </a:rPr>
+              <a:t>→  —  QUALIFICATION &amp; NOMENCLATURE — POINTS CLÉS</a:t>
+            </a:r>
+          </a:p>
+        </p:txBody>
+      </p:sp>
+      <p:sp>
+        <p:nvSpPr>
+          <p:cNvPr id="5" name="TextBox 4"/>
+          <p:cNvSpPr txBox="1"/>
+          <p:nvPr/>
+        </p:nvSpPr>
+        <p:spPr>
+          <a:xfrm>
+            <a:off x="365760" y="658368"/>
+            <a:ext cx="11430000" cy="402336"/>
+          </a:xfrm>
+          <a:prstGeom prst="rect">
+            <a:avLst/>
+          </a:prstGeom>
+          <a:noFill/>
+        </p:spPr>
+        <p:txBody>
+          <a:bodyPr wrap="square">
+            <a:spAutoFit/>
+          </a:bodyPr>
+          <a:lstStyle/>
+          <a:p>
+            <a:pPr algn="l"/>
+            <a:r>
+              <a:rPr sz="1200" b="0" i="1">
+                <a:solidFill>
+                  <a:srgbClr val="00AEEF"/>
+                </a:solidFill>
+                <a:latin typeface="Segoe UI"/>
+              </a:rPr>
+              <a:t>50 % de la qualité Fidelis repose sur une qualification CONFORME</a:t>
+            </a:r>
+          </a:p>
+        </p:txBody>
+      </p:sp>
+      <p:sp>
+        <p:nvSpPr>
+          <p:cNvPr id="6" name="Rectangle 5"/>
+          <p:cNvSpPr/>
+          <p:nvPr/>
+        </p:nvSpPr>
+        <p:spPr>
+          <a:xfrm>
+            <a:off x="0" y="6492240"/>
+            <a:ext cx="12188952" cy="365760"/>
+          </a:xfrm>
+          <a:prstGeom prst="rect">
+            <a:avLst/>
+          </a:prstGeom>
+          <a:solidFill>
+            <a:srgbClr val="003087"/>
+          </a:solidFill>
+          <a:ln>
+            <a:noFill/>
+          </a:ln>
+        </p:spPr>
+        <p:style>
+          <a:lnRef idx="1">
+            <a:schemeClr val="accent1"/>
+          </a:lnRef>
+          <a:fillRef idx="3">
+            <a:schemeClr val="accent1"/>
+          </a:fillRef>
+          <a:effectRef idx="2">
+            <a:schemeClr val="accent1"/>
+          </a:effectRef>
+          <a:fontRef idx="minor">
+            <a:schemeClr val="lt1"/>
+          </a:fontRef>
+        </p:style>
+        <p:txBody>
+          <a:bodyPr rtlCol="0" anchor="ctr"/>
+          <a:lstStyle/>
+          <a:p>
+            <a:pPr algn="ctr"/>
+          </a:p>
+        </p:txBody>
+      </p:sp>
+      <p:sp>
+        <p:nvSpPr>
+          <p:cNvPr id="7" name="TextBox 6"/>
+          <p:cNvSpPr txBox="1"/>
+          <p:nvPr/>
+        </p:nvSpPr>
+        <p:spPr>
+          <a:xfrm>
+            <a:off x="274320" y="6510528"/>
+            <a:ext cx="11640312" cy="310896"/>
+          </a:xfrm>
+          <a:prstGeom prst="rect">
+            <a:avLst/>
+          </a:prstGeom>
+          <a:noFill/>
+        </p:spPr>
+        <p:txBody>
+          <a:bodyPr wrap="square">
+            <a:spAutoFit/>
+          </a:bodyPr>
+          <a:lstStyle/>
+          <a:p>
+            <a:pPr algn="ctr"/>
+            <a:r>
+              <a:rPr sz="900" b="0" i="0">
+                <a:solidFill>
+                  <a:srgbClr val="AABBDD"/>
+                </a:solidFill>
+                <a:latin typeface="Segoe UI"/>
+              </a:rPr>
+              <a:t>SYNTHÈSE J2 Matinée  |  Réveil Pédagogique  |  Fidelis × SHY Performance</a:t>
+            </a:r>
+          </a:p>
+        </p:txBody>
+      </p:sp>
+      <p:sp>
+        <p:nvSpPr>
+          <p:cNvPr id="8" name="Rectangle 7"/>
+          <p:cNvSpPr/>
+          <p:nvPr/>
+        </p:nvSpPr>
+        <p:spPr>
+          <a:xfrm>
+            <a:off x="320040" y="1371600"/>
+            <a:ext cx="11521440" cy="804672"/>
+          </a:xfrm>
+          <a:prstGeom prst="rect">
+            <a:avLst/>
+          </a:prstGeom>
+          <a:solidFill>
+            <a:srgbClr val="0A1628"/>
+          </a:solidFill>
+          <a:ln w="19050">
+            <a:solidFill>
+              <a:srgbClr val="E74C3C"/>
+            </a:solidFill>
+          </a:ln>
+        </p:spPr>
+        <p:style>
+          <a:lnRef idx="1">
+            <a:schemeClr val="accent1"/>
+          </a:lnRef>
+          <a:fillRef idx="3">
+            <a:schemeClr val="accent1"/>
+          </a:fillRef>
+          <a:effectRef idx="2">
+            <a:schemeClr val="accent1"/>
+          </a:effectRef>
+          <a:fontRef idx="minor">
+            <a:schemeClr val="lt1"/>
+          </a:fontRef>
+        </p:style>
+        <p:txBody>
+          <a:bodyPr rtlCol="0" anchor="ctr"/>
+          <a:lstStyle/>
+          <a:p>
+            <a:pPr algn="ctr"/>
+          </a:p>
+        </p:txBody>
+      </p:sp>
+      <p:sp>
+        <p:nvSpPr>
+          <p:cNvPr id="9" name="Rectangle 8"/>
+          <p:cNvSpPr/>
+          <p:nvPr/>
+        </p:nvSpPr>
+        <p:spPr>
+          <a:xfrm>
+            <a:off x="320040" y="1371600"/>
+            <a:ext cx="11521440" cy="45720"/>
+          </a:xfrm>
+          <a:prstGeom prst="rect">
+            <a:avLst/>
+          </a:prstGeom>
+          <a:solidFill>
+            <a:srgbClr val="E74C3C"/>
+          </a:solidFill>
+          <a:ln>
+            <a:noFill/>
+          </a:ln>
+        </p:spPr>
+        <p:style>
+          <a:lnRef idx="1">
+            <a:schemeClr val="accent1"/>
+          </a:lnRef>
+          <a:fillRef idx="3">
+            <a:schemeClr val="accent1"/>
+          </a:fillRef>
+          <a:effectRef idx="2">
+            <a:schemeClr val="accent1"/>
+          </a:effectRef>
+          <a:fontRef idx="minor">
+            <a:schemeClr val="lt1"/>
+          </a:fontRef>
+        </p:style>
+        <p:txBody>
+          <a:bodyPr rtlCol="0" anchor="ctr"/>
+          <a:lstStyle/>
+          <a:p>
+            <a:pPr algn="ctr"/>
+          </a:p>
+        </p:txBody>
+      </p:sp>
+      <p:sp>
+        <p:nvSpPr>
+          <p:cNvPr id="10" name="TextBox 9"/>
+          <p:cNvSpPr txBox="1"/>
+          <p:nvPr/>
+        </p:nvSpPr>
+        <p:spPr>
+          <a:xfrm>
+            <a:off x="502920" y="1481328"/>
+            <a:ext cx="10972800" cy="219456"/>
+          </a:xfrm>
+          <a:prstGeom prst="rect">
+            <a:avLst/>
+          </a:prstGeom>
+          <a:noFill/>
+        </p:spPr>
+        <p:txBody>
+          <a:bodyPr wrap="square">
+            <a:spAutoFit/>
+          </a:bodyPr>
+          <a:lstStyle/>
+          <a:p>
+            <a:pPr algn="l"/>
+            <a:r>
+              <a:rPr sz="1000" b="1" i="0">
+                <a:solidFill>
+                  <a:srgbClr val="E74C3C"/>
+                </a:solidFill>
+                <a:latin typeface="Segoe UI"/>
+              </a:rPr>
+              <a:t>IMPACT D'UNE FAUSSE QUALIFICATION</a:t>
+            </a:r>
+          </a:p>
+        </p:txBody>
+      </p:sp>
+      <p:sp>
+        <p:nvSpPr>
+          <p:cNvPr id="11" name="TextBox 10"/>
+          <p:cNvSpPr txBox="1"/>
+          <p:nvPr/>
+        </p:nvSpPr>
+        <p:spPr>
+          <a:xfrm>
+            <a:off x="502920" y="1737360"/>
+            <a:ext cx="10972800" cy="384048"/>
+          </a:xfrm>
+          <a:prstGeom prst="rect">
+            <a:avLst/>
+          </a:prstGeom>
+          <a:noFill/>
+        </p:spPr>
+        <p:txBody>
+          <a:bodyPr wrap="square">
+            <a:spAutoFit/>
+          </a:bodyPr>
+          <a:lstStyle/>
+          <a:p>
+            <a:pPr algn="l"/>
+            <a:r>
+              <a:rPr sz="1000" b="0" i="0">
+                <a:solidFill>
+                  <a:srgbClr val="FFFFFF"/>
+                </a:solidFill>
+                <a:latin typeface="Segoe UI"/>
+              </a:rPr>
+              <a:t>Refus Argumenté / Refus de Répondre = non contacté 4 mois UNICEF.  SHY Performance &amp; Nescall : 300 000 – 400 000 fiches/mois chacun. Chaque fiche mal qualifiée = contact perdu.</a:t>
+            </a:r>
+          </a:p>
+        </p:txBody>
+      </p:sp>
+      <p:sp>
+        <p:nvSpPr>
+          <p:cNvPr id="12" name="Rectangle 11"/>
+          <p:cNvSpPr/>
+          <p:nvPr/>
+        </p:nvSpPr>
+        <p:spPr>
+          <a:xfrm>
+            <a:off x="320040" y="2304288"/>
+            <a:ext cx="11521440" cy="365760"/>
+          </a:xfrm>
+          <a:prstGeom prst="rect">
+            <a:avLst/>
+          </a:prstGeom>
+          <a:solidFill>
+            <a:srgbClr val="EAFAF1"/>
+          </a:solidFill>
+          <a:ln w="6350">
+            <a:solidFill>
+              <a:srgbClr val="DCE3F0"/>
+            </a:solidFill>
+          </a:ln>
+        </p:spPr>
+        <p:style>
+          <a:lnRef idx="1">
+            <a:schemeClr val="accent1"/>
+          </a:lnRef>
+          <a:fillRef idx="3">
+            <a:schemeClr val="accent1"/>
+          </a:fillRef>
+          <a:effectRef idx="2">
+            <a:schemeClr val="accent1"/>
+          </a:effectRef>
+          <a:fontRef idx="minor">
+            <a:schemeClr val="lt1"/>
+          </a:fontRef>
+        </p:style>
+        <p:txBody>
+          <a:bodyPr rtlCol="0" anchor="ctr"/>
+          <a:lstStyle/>
+          <a:p>
+            <a:pPr algn="ctr"/>
+          </a:p>
+        </p:txBody>
+      </p:sp>
+      <p:sp>
+        <p:nvSpPr>
+          <p:cNvPr id="13" name="Rectangle 12"/>
+          <p:cNvSpPr/>
+          <p:nvPr/>
+        </p:nvSpPr>
+        <p:spPr>
+          <a:xfrm>
+            <a:off x="320040" y="2304288"/>
+            <a:ext cx="54864" cy="365760"/>
+          </a:xfrm>
+          <a:prstGeom prst="rect">
+            <a:avLst/>
+          </a:prstGeom>
+          <a:solidFill>
+            <a:srgbClr val="27AE60"/>
+          </a:solidFill>
+          <a:ln>
+            <a:noFill/>
+          </a:ln>
+        </p:spPr>
+        <p:style>
+          <a:lnRef idx="1">
+            <a:schemeClr val="accent1"/>
+          </a:lnRef>
+          <a:fillRef idx="3">
+            <a:schemeClr val="accent1"/>
+          </a:fillRef>
+          <a:effectRef idx="2">
+            <a:schemeClr val="accent1"/>
+          </a:effectRef>
+          <a:fontRef idx="minor">
+            <a:schemeClr val="lt1"/>
+          </a:fontRef>
+        </p:style>
+        <p:txBody>
+          <a:bodyPr rtlCol="0" anchor="ctr"/>
+          <a:lstStyle/>
+          <a:p>
+            <a:pPr algn="ctr"/>
+          </a:p>
+        </p:txBody>
+      </p:sp>
+      <p:sp>
+        <p:nvSpPr>
+          <p:cNvPr id="14" name="TextBox 13"/>
+          <p:cNvSpPr txBox="1"/>
+          <p:nvPr/>
+        </p:nvSpPr>
+        <p:spPr>
+          <a:xfrm>
+            <a:off x="502920" y="2368296"/>
+            <a:ext cx="2011680" cy="237744"/>
+          </a:xfrm>
+          <a:prstGeom prst="rect">
+            <a:avLst/>
+          </a:prstGeom>
+          <a:noFill/>
+        </p:spPr>
+        <p:txBody>
+          <a:bodyPr wrap="square">
+            <a:spAutoFit/>
+          </a:bodyPr>
+          <a:lstStyle/>
+          <a:p>
+            <a:pPr algn="l"/>
+            <a:r>
+              <a:rPr sz="1000" b="1" i="0">
+                <a:solidFill>
+                  <a:srgbClr val="003087"/>
+                </a:solidFill>
+                <a:latin typeface="Segoe UI"/>
+              </a:rPr>
+              <a:t>✅  PEL</a:t>
+            </a:r>
+          </a:p>
+        </p:txBody>
+      </p:sp>
+      <p:sp>
+        <p:nvSpPr>
+          <p:cNvPr id="15" name="TextBox 14"/>
+          <p:cNvSpPr txBox="1"/>
+          <p:nvPr/>
+        </p:nvSpPr>
+        <p:spPr>
+          <a:xfrm>
+            <a:off x="2606040" y="2368296"/>
+            <a:ext cx="8961120" cy="237744"/>
+          </a:xfrm>
+          <a:prstGeom prst="rect">
+            <a:avLst/>
+          </a:prstGeom>
+          <a:noFill/>
+        </p:spPr>
+        <p:txBody>
+          <a:bodyPr wrap="square">
+            <a:spAutoFit/>
+          </a:bodyPr>
+          <a:lstStyle/>
+          <a:p>
+            <a:pPr algn="l"/>
+            <a:r>
+              <a:rPr sz="1000" b="0" i="0">
+                <a:solidFill>
+                  <a:srgbClr val="555555"/>
+                </a:solidFill>
+                <a:latin typeface="Segoe UI"/>
+              </a:rPr>
+              <a:t>Prélèvement En Ligne — mission accomplie</a:t>
+            </a:r>
+          </a:p>
+        </p:txBody>
+      </p:sp>
+      <p:sp>
+        <p:nvSpPr>
+          <p:cNvPr id="16" name="Rectangle 15"/>
+          <p:cNvSpPr/>
+          <p:nvPr/>
+        </p:nvSpPr>
+        <p:spPr>
+          <a:xfrm>
+            <a:off x="320040" y="2679192"/>
+            <a:ext cx="11521440" cy="365760"/>
+          </a:xfrm>
+          <a:prstGeom prst="rect">
+            <a:avLst/>
+          </a:prstGeom>
+          <a:solidFill>
+            <a:srgbClr val="EAFAF1"/>
+          </a:solidFill>
+          <a:ln w="6350">
+            <a:solidFill>
+              <a:srgbClr val="DCE3F0"/>
+            </a:solidFill>
+          </a:ln>
+        </p:spPr>
+        <p:style>
+          <a:lnRef idx="1">
+            <a:schemeClr val="accent1"/>
+          </a:lnRef>
+          <a:fillRef idx="3">
+            <a:schemeClr val="accent1"/>
+          </a:fillRef>
+          <a:effectRef idx="2">
+            <a:schemeClr val="accent1"/>
+          </a:effectRef>
+          <a:fontRef idx="minor">
+            <a:schemeClr val="lt1"/>
+          </a:fontRef>
+        </p:style>
+        <p:txBody>
+          <a:bodyPr rtlCol="0" anchor="ctr"/>
+          <a:lstStyle/>
+          <a:p>
+            <a:pPr algn="ctr"/>
+          </a:p>
+        </p:txBody>
+      </p:sp>
+      <p:sp>
+        <p:nvSpPr>
+          <p:cNvPr id="17" name="Rectangle 16"/>
+          <p:cNvSpPr/>
+          <p:nvPr/>
+        </p:nvSpPr>
+        <p:spPr>
+          <a:xfrm>
+            <a:off x="320040" y="2679192"/>
+            <a:ext cx="54864" cy="365760"/>
+          </a:xfrm>
+          <a:prstGeom prst="rect">
+            <a:avLst/>
+          </a:prstGeom>
+          <a:solidFill>
+            <a:srgbClr val="27AE60"/>
+          </a:solidFill>
+          <a:ln>
+            <a:noFill/>
+          </a:ln>
+        </p:spPr>
+        <p:style>
+          <a:lnRef idx="1">
+            <a:schemeClr val="accent1"/>
+          </a:lnRef>
+          <a:fillRef idx="3">
+            <a:schemeClr val="accent1"/>
+          </a:fillRef>
+          <a:effectRef idx="2">
+            <a:schemeClr val="accent1"/>
+          </a:effectRef>
+          <a:fontRef idx="minor">
+            <a:schemeClr val="lt1"/>
+          </a:fontRef>
+        </p:style>
+        <p:txBody>
+          <a:bodyPr rtlCol="0" anchor="ctr"/>
+          <a:lstStyle/>
+          <a:p>
+            <a:pPr algn="ctr"/>
+          </a:p>
+        </p:txBody>
+      </p:sp>
+      <p:sp>
+        <p:nvSpPr>
+          <p:cNvPr id="18" name="TextBox 17"/>
+          <p:cNvSpPr txBox="1"/>
+          <p:nvPr/>
+        </p:nvSpPr>
+        <p:spPr>
+          <a:xfrm>
+            <a:off x="502920" y="2743200"/>
+            <a:ext cx="2011680" cy="237744"/>
+          </a:xfrm>
+          <a:prstGeom prst="rect">
+            <a:avLst/>
+          </a:prstGeom>
+          <a:noFill/>
+        </p:spPr>
+        <p:txBody>
+          <a:bodyPr wrap="square">
+            <a:spAutoFit/>
+          </a:bodyPr>
+          <a:lstStyle/>
+          <a:p>
+            <a:pPr algn="l"/>
+            <a:r>
+              <a:rPr sz="1000" b="1" i="0">
+                <a:solidFill>
+                  <a:srgbClr val="003087"/>
+                </a:solidFill>
+                <a:latin typeface="Segoe UI"/>
+              </a:rPr>
+              <a:t>✅  RIM</a:t>
+            </a:r>
+          </a:p>
+        </p:txBody>
+      </p:sp>
+      <p:sp>
+        <p:nvSpPr>
+          <p:cNvPr id="19" name="TextBox 18"/>
+          <p:cNvSpPr txBox="1"/>
+          <p:nvPr/>
+        </p:nvSpPr>
+        <p:spPr>
+          <a:xfrm>
+            <a:off x="2606040" y="2743200"/>
+            <a:ext cx="8961120" cy="237744"/>
+          </a:xfrm>
+          <a:prstGeom prst="rect">
+            <a:avLst/>
+          </a:prstGeom>
+          <a:noFill/>
+        </p:spPr>
+        <p:txBody>
+          <a:bodyPr wrap="square">
+            <a:spAutoFit/>
+          </a:bodyPr>
+          <a:lstStyle/>
+          <a:p>
+            <a:pPr algn="l"/>
+            <a:r>
+              <a:rPr sz="1000" b="0" i="0">
+                <a:solidFill>
+                  <a:srgbClr val="555555"/>
+                </a:solidFill>
+                <a:latin typeface="Segoe UI"/>
+              </a:rPr>
+              <a:t>Rappel Imminent — intéressé, à rappeler vite</a:t>
+            </a:r>
+          </a:p>
+        </p:txBody>
+      </p:sp>
+      <p:sp>
+        <p:nvSpPr>
+          <p:cNvPr id="20" name="Rectangle 19"/>
+          <p:cNvSpPr/>
+          <p:nvPr/>
+        </p:nvSpPr>
+        <p:spPr>
+          <a:xfrm>
+            <a:off x="320040" y="3054096"/>
+            <a:ext cx="11521440" cy="365760"/>
+          </a:xfrm>
+          <a:prstGeom prst="rect">
+            <a:avLst/>
+          </a:prstGeom>
+          <a:solidFill>
+            <a:srgbClr val="F0FDFA"/>
+          </a:solidFill>
+          <a:ln w="6350">
+            <a:solidFill>
+              <a:srgbClr val="DCE3F0"/>
+            </a:solidFill>
+          </a:ln>
+        </p:spPr>
+        <p:style>
+          <a:lnRef idx="1">
+            <a:schemeClr val="accent1"/>
+          </a:lnRef>
+          <a:fillRef idx="3">
+            <a:schemeClr val="accent1"/>
+          </a:fillRef>
+          <a:effectRef idx="2">
+            <a:schemeClr val="accent1"/>
+          </a:effectRef>
+          <a:fontRef idx="minor">
+            <a:schemeClr val="lt1"/>
+          </a:fontRef>
+        </p:style>
+        <p:txBody>
+          <a:bodyPr rtlCol="0" anchor="ctr"/>
+          <a:lstStyle/>
+          <a:p>
+            <a:pPr algn="ctr"/>
+          </a:p>
+        </p:txBody>
+      </p:sp>
+      <p:sp>
+        <p:nvSpPr>
+          <p:cNvPr id="21" name="Rectangle 20"/>
+          <p:cNvSpPr/>
+          <p:nvPr/>
+        </p:nvSpPr>
+        <p:spPr>
+          <a:xfrm>
+            <a:off x="320040" y="3054096"/>
+            <a:ext cx="54864" cy="365760"/>
+          </a:xfrm>
+          <a:prstGeom prst="rect">
+            <a:avLst/>
+          </a:prstGeom>
+          <a:solidFill>
+            <a:srgbClr val="0D9488"/>
+          </a:solidFill>
+          <a:ln>
+            <a:noFill/>
+          </a:ln>
+        </p:spPr>
+        <p:style>
+          <a:lnRef idx="1">
+            <a:schemeClr val="accent1"/>
+          </a:lnRef>
+          <a:fillRef idx="3">
+            <a:schemeClr val="accent1"/>
+          </a:fillRef>
+          <a:effectRef idx="2">
+            <a:schemeClr val="accent1"/>
+          </a:effectRef>
+          <a:fontRef idx="minor">
+            <a:schemeClr val="lt1"/>
+          </a:fontRef>
+        </p:style>
+        <p:txBody>
+          <a:bodyPr rtlCol="0" anchor="ctr"/>
+          <a:lstStyle/>
+          <a:p>
+            <a:pPr algn="ctr"/>
+          </a:p>
+        </p:txBody>
+      </p:sp>
+      <p:sp>
+        <p:nvSpPr>
+          <p:cNvPr id="22" name="TextBox 21"/>
+          <p:cNvSpPr txBox="1"/>
+          <p:nvPr/>
+        </p:nvSpPr>
+        <p:spPr>
+          <a:xfrm>
+            <a:off x="502920" y="3118104"/>
+            <a:ext cx="2011680" cy="237744"/>
+          </a:xfrm>
+          <a:prstGeom prst="rect">
+            <a:avLst/>
+          </a:prstGeom>
+          <a:noFill/>
+        </p:spPr>
+        <p:txBody>
+          <a:bodyPr wrap="square">
+            <a:spAutoFit/>
+          </a:bodyPr>
+          <a:lstStyle/>
+          <a:p>
+            <a:pPr algn="l"/>
+            <a:r>
+              <a:rPr sz="1000" b="1" i="0">
+                <a:solidFill>
+                  <a:srgbClr val="003087"/>
+                </a:solidFill>
+                <a:latin typeface="Segoe UI"/>
+              </a:rPr>
+              <a:t>🕐  ABSENT</a:t>
+            </a:r>
+          </a:p>
+        </p:txBody>
+      </p:sp>
+      <p:sp>
+        <p:nvSpPr>
+          <p:cNvPr id="23" name="TextBox 22"/>
+          <p:cNvSpPr txBox="1"/>
+          <p:nvPr/>
+        </p:nvSpPr>
+        <p:spPr>
+          <a:xfrm>
+            <a:off x="2606040" y="3118104"/>
+            <a:ext cx="8961120" cy="237744"/>
+          </a:xfrm>
+          <a:prstGeom prst="rect">
+            <a:avLst/>
+          </a:prstGeom>
+          <a:noFill/>
+        </p:spPr>
+        <p:txBody>
+          <a:bodyPr wrap="square">
+            <a:spAutoFit/>
+          </a:bodyPr>
+          <a:lstStyle/>
+          <a:p>
+            <a:pPr algn="l"/>
+            <a:r>
+              <a:rPr sz="1000" b="0" i="0">
+                <a:solidFill>
+                  <a:srgbClr val="555555"/>
+                </a:solidFill>
+                <a:latin typeface="Segoe UI"/>
+              </a:rPr>
+              <a:t>Répondeur / NRP / Raccroché SANS identification — PAS un refus</a:t>
+            </a:r>
+          </a:p>
+        </p:txBody>
+      </p:sp>
+      <p:sp>
+        <p:nvSpPr>
+          <p:cNvPr id="24" name="Rectangle 23"/>
+          <p:cNvSpPr/>
+          <p:nvPr/>
+        </p:nvSpPr>
+        <p:spPr>
+          <a:xfrm>
+            <a:off x="320040" y="3429000"/>
+            <a:ext cx="11521440" cy="365760"/>
+          </a:xfrm>
+          <a:prstGeom prst="rect">
+            <a:avLst/>
+          </a:prstGeom>
+          <a:solidFill>
+            <a:srgbClr val="F0FDFA"/>
+          </a:solidFill>
+          <a:ln w="6350">
+            <a:solidFill>
+              <a:srgbClr val="DCE3F0"/>
+            </a:solidFill>
+          </a:ln>
+        </p:spPr>
+        <p:style>
+          <a:lnRef idx="1">
+            <a:schemeClr val="accent1"/>
+          </a:lnRef>
+          <a:fillRef idx="3">
+            <a:schemeClr val="accent1"/>
+          </a:fillRef>
+          <a:effectRef idx="2">
+            <a:schemeClr val="accent1"/>
+          </a:effectRef>
+          <a:fontRef idx="minor">
+            <a:schemeClr val="lt1"/>
+          </a:fontRef>
+        </p:style>
+        <p:txBody>
+          <a:bodyPr rtlCol="0" anchor="ctr"/>
+          <a:lstStyle/>
+          <a:p>
+            <a:pPr algn="ctr"/>
+          </a:p>
+        </p:txBody>
+      </p:sp>
+      <p:sp>
+        <p:nvSpPr>
+          <p:cNvPr id="25" name="Rectangle 24"/>
+          <p:cNvSpPr/>
+          <p:nvPr/>
+        </p:nvSpPr>
+        <p:spPr>
+          <a:xfrm>
+            <a:off x="320040" y="3429000"/>
+            <a:ext cx="54864" cy="365760"/>
+          </a:xfrm>
+          <a:prstGeom prst="rect">
+            <a:avLst/>
+          </a:prstGeom>
+          <a:solidFill>
+            <a:srgbClr val="0D9488"/>
+          </a:solidFill>
+          <a:ln>
+            <a:noFill/>
+          </a:ln>
+        </p:spPr>
+        <p:style>
+          <a:lnRef idx="1">
+            <a:schemeClr val="accent1"/>
+          </a:lnRef>
+          <a:fillRef idx="3">
+            <a:schemeClr val="accent1"/>
+          </a:fillRef>
+          <a:effectRef idx="2">
+            <a:schemeClr val="accent1"/>
+          </a:effectRef>
+          <a:fontRef idx="minor">
+            <a:schemeClr val="lt1"/>
+          </a:fontRef>
+        </p:style>
+        <p:txBody>
+          <a:bodyPr rtlCol="0" anchor="ctr"/>
+          <a:lstStyle/>
+          <a:p>
+            <a:pPr algn="ctr"/>
+          </a:p>
+        </p:txBody>
+      </p:sp>
+      <p:sp>
+        <p:nvSpPr>
+          <p:cNvPr id="26" name="TextBox 25"/>
+          <p:cNvSpPr txBox="1"/>
+          <p:nvPr/>
+        </p:nvSpPr>
+        <p:spPr>
+          <a:xfrm>
+            <a:off x="502920" y="3493008"/>
+            <a:ext cx="2011680" cy="237744"/>
+          </a:xfrm>
+          <a:prstGeom prst="rect">
+            <a:avLst/>
+          </a:prstGeom>
+          <a:noFill/>
+        </p:spPr>
+        <p:txBody>
+          <a:bodyPr wrap="square">
+            <a:spAutoFit/>
+          </a:bodyPr>
+          <a:lstStyle/>
+          <a:p>
+            <a:pPr algn="l"/>
+            <a:r>
+              <a:rPr sz="1000" b="1" i="0">
+                <a:solidFill>
+                  <a:srgbClr val="003087"/>
+                </a:solidFill>
+                <a:latin typeface="Segoe UI"/>
+              </a:rPr>
+              <a:t>🕐  DEL</a:t>
+            </a:r>
+          </a:p>
+        </p:txBody>
+      </p:sp>
+      <p:sp>
+        <p:nvSpPr>
+          <p:cNvPr id="27" name="TextBox 26"/>
+          <p:cNvSpPr txBox="1"/>
+          <p:nvPr/>
+        </p:nvSpPr>
+        <p:spPr>
+          <a:xfrm>
+            <a:off x="2606040" y="3493008"/>
+            <a:ext cx="8961120" cy="237744"/>
+          </a:xfrm>
+          <a:prstGeom prst="rect">
+            <a:avLst/>
+          </a:prstGeom>
+          <a:noFill/>
+        </p:spPr>
+        <p:txBody>
+          <a:bodyPr wrap="square">
+            <a:spAutoFit/>
+          </a:bodyPr>
+          <a:lstStyle/>
+          <a:p>
+            <a:pPr algn="l"/>
+            <a:r>
+              <a:rPr sz="1000" b="0" i="0">
+                <a:solidFill>
+                  <a:srgbClr val="555555"/>
+                </a:solidFill>
+                <a:latin typeface="Segoe UI"/>
+              </a:rPr>
+              <a:t>Don En Ligne — préfère donner via lien web</a:t>
+            </a:r>
+          </a:p>
+        </p:txBody>
+      </p:sp>
+      <p:sp>
+        <p:nvSpPr>
+          <p:cNvPr id="28" name="Rectangle 27"/>
+          <p:cNvSpPr/>
+          <p:nvPr/>
+        </p:nvSpPr>
+        <p:spPr>
+          <a:xfrm>
+            <a:off x="320040" y="3803904"/>
+            <a:ext cx="11521440" cy="365760"/>
+          </a:xfrm>
+          <a:prstGeom prst="rect">
+            <a:avLst/>
+          </a:prstGeom>
+          <a:solidFill>
+            <a:srgbClr val="FDF0EF"/>
+          </a:solidFill>
+          <a:ln w="6350">
+            <a:solidFill>
+              <a:srgbClr val="DCE3F0"/>
+            </a:solidFill>
+          </a:ln>
+        </p:spPr>
+        <p:style>
+          <a:lnRef idx="1">
+            <a:schemeClr val="accent1"/>
+          </a:lnRef>
+          <a:fillRef idx="3">
+            <a:schemeClr val="accent1"/>
+          </a:fillRef>
+          <a:effectRef idx="2">
+            <a:schemeClr val="accent1"/>
+          </a:effectRef>
+          <a:fontRef idx="minor">
+            <a:schemeClr val="lt1"/>
+          </a:fontRef>
+        </p:style>
+        <p:txBody>
+          <a:bodyPr rtlCol="0" anchor="ctr"/>
+          <a:lstStyle/>
+          <a:p>
+            <a:pPr algn="ctr"/>
+          </a:p>
+        </p:txBody>
+      </p:sp>
+      <p:sp>
+        <p:nvSpPr>
+          <p:cNvPr id="29" name="Rectangle 28"/>
+          <p:cNvSpPr/>
+          <p:nvPr/>
+        </p:nvSpPr>
+        <p:spPr>
+          <a:xfrm>
+            <a:off x="320040" y="3803904"/>
+            <a:ext cx="54864" cy="365760"/>
+          </a:xfrm>
+          <a:prstGeom prst="rect">
+            <a:avLst/>
+          </a:prstGeom>
+          <a:solidFill>
+            <a:srgbClr val="E74C3C"/>
+          </a:solidFill>
+          <a:ln>
+            <a:noFill/>
+          </a:ln>
+        </p:spPr>
+        <p:style>
+          <a:lnRef idx="1">
+            <a:schemeClr val="accent1"/>
+          </a:lnRef>
+          <a:fillRef idx="3">
+            <a:schemeClr val="accent1"/>
+          </a:fillRef>
+          <a:effectRef idx="2">
+            <a:schemeClr val="accent1"/>
+          </a:effectRef>
+          <a:fontRef idx="minor">
+            <a:schemeClr val="lt1"/>
+          </a:fontRef>
+        </p:style>
+        <p:txBody>
+          <a:bodyPr rtlCol="0" anchor="ctr"/>
+          <a:lstStyle/>
+          <a:p>
+            <a:pPr algn="ctr"/>
+          </a:p>
+        </p:txBody>
+      </p:sp>
+      <p:sp>
+        <p:nvSpPr>
+          <p:cNvPr id="30" name="TextBox 29"/>
+          <p:cNvSpPr txBox="1"/>
+          <p:nvPr/>
+        </p:nvSpPr>
+        <p:spPr>
+          <a:xfrm>
+            <a:off x="502920" y="3867912"/>
+            <a:ext cx="2011680" cy="237744"/>
+          </a:xfrm>
+          <a:prstGeom prst="rect">
+            <a:avLst/>
+          </a:prstGeom>
+          <a:noFill/>
+        </p:spPr>
+        <p:txBody>
+          <a:bodyPr wrap="square">
+            <a:spAutoFit/>
+          </a:bodyPr>
+          <a:lstStyle/>
+          <a:p>
+            <a:pPr algn="l"/>
+            <a:r>
+              <a:rPr sz="1000" b="1" i="0">
+                <a:solidFill>
+                  <a:srgbClr val="003087"/>
+                </a:solidFill>
+                <a:latin typeface="Segoe UI"/>
+              </a:rPr>
+              <a:t>❌  RA</a:t>
+            </a:r>
+          </a:p>
+        </p:txBody>
+      </p:sp>
+      <p:sp>
+        <p:nvSpPr>
+          <p:cNvPr id="31" name="TextBox 30"/>
+          <p:cNvSpPr txBox="1"/>
+          <p:nvPr/>
+        </p:nvSpPr>
+        <p:spPr>
+          <a:xfrm>
+            <a:off x="2606040" y="3867912"/>
+            <a:ext cx="8961120" cy="237744"/>
+          </a:xfrm>
+          <a:prstGeom prst="rect">
+            <a:avLst/>
+          </a:prstGeom>
+          <a:noFill/>
+        </p:spPr>
+        <p:txBody>
+          <a:bodyPr wrap="square">
+            <a:spAutoFit/>
+          </a:bodyPr>
+          <a:lstStyle/>
+          <a:p>
+            <a:pPr algn="l"/>
+            <a:r>
+              <a:rPr sz="1000" b="0" i="0">
+                <a:solidFill>
+                  <a:srgbClr val="555555"/>
+                </a:solidFill>
+                <a:latin typeface="Segoe UI"/>
+              </a:rPr>
+              <a:t>Refus Argumenté — raison valide — 4 mois sans contact UNICEF</a:t>
+            </a:r>
+          </a:p>
+        </p:txBody>
+      </p:sp>
+      <p:sp>
+        <p:nvSpPr>
+          <p:cNvPr id="32" name="Rectangle 31"/>
+          <p:cNvSpPr/>
+          <p:nvPr/>
+        </p:nvSpPr>
+        <p:spPr>
+          <a:xfrm>
+            <a:off x="320040" y="4178808"/>
+            <a:ext cx="11521440" cy="365760"/>
+          </a:xfrm>
+          <a:prstGeom prst="rect">
+            <a:avLst/>
+          </a:prstGeom>
+          <a:solidFill>
+            <a:srgbClr val="FDF0EF"/>
+          </a:solidFill>
+          <a:ln w="6350">
+            <a:solidFill>
+              <a:srgbClr val="DCE3F0"/>
+            </a:solidFill>
+          </a:ln>
+        </p:spPr>
+        <p:style>
+          <a:lnRef idx="1">
+            <a:schemeClr val="accent1"/>
+          </a:lnRef>
+          <a:fillRef idx="3">
+            <a:schemeClr val="accent1"/>
+          </a:fillRef>
+          <a:effectRef idx="2">
+            <a:schemeClr val="accent1"/>
+          </a:effectRef>
+          <a:fontRef idx="minor">
+            <a:schemeClr val="lt1"/>
+          </a:fontRef>
+        </p:style>
+        <p:txBody>
+          <a:bodyPr rtlCol="0" anchor="ctr"/>
+          <a:lstStyle/>
+          <a:p>
+            <a:pPr algn="ctr"/>
+          </a:p>
+        </p:txBody>
+      </p:sp>
+      <p:sp>
+        <p:nvSpPr>
+          <p:cNvPr id="33" name="Rectangle 32"/>
+          <p:cNvSpPr/>
+          <p:nvPr/>
+        </p:nvSpPr>
+        <p:spPr>
+          <a:xfrm>
+            <a:off x="320040" y="4178808"/>
+            <a:ext cx="54864" cy="365760"/>
+          </a:xfrm>
+          <a:prstGeom prst="rect">
+            <a:avLst/>
+          </a:prstGeom>
+          <a:solidFill>
+            <a:srgbClr val="E74C3C"/>
+          </a:solidFill>
+          <a:ln>
+            <a:noFill/>
+          </a:ln>
+        </p:spPr>
+        <p:style>
+          <a:lnRef idx="1">
+            <a:schemeClr val="accent1"/>
+          </a:lnRef>
+          <a:fillRef idx="3">
+            <a:schemeClr val="accent1"/>
+          </a:fillRef>
+          <a:effectRef idx="2">
+            <a:schemeClr val="accent1"/>
+          </a:effectRef>
+          <a:fontRef idx="minor">
+            <a:schemeClr val="lt1"/>
+          </a:fontRef>
+        </p:style>
+        <p:txBody>
+          <a:bodyPr rtlCol="0" anchor="ctr"/>
+          <a:lstStyle/>
+          <a:p>
+            <a:pPr algn="ctr"/>
+          </a:p>
+        </p:txBody>
+      </p:sp>
+      <p:sp>
+        <p:nvSpPr>
+          <p:cNvPr id="34" name="TextBox 33"/>
+          <p:cNvSpPr txBox="1"/>
+          <p:nvPr/>
+        </p:nvSpPr>
+        <p:spPr>
+          <a:xfrm>
+            <a:off x="502920" y="4242816"/>
+            <a:ext cx="2011680" cy="237744"/>
+          </a:xfrm>
+          <a:prstGeom prst="rect">
+            <a:avLst/>
+          </a:prstGeom>
+          <a:noFill/>
+        </p:spPr>
+        <p:txBody>
+          <a:bodyPr wrap="square">
+            <a:spAutoFit/>
+          </a:bodyPr>
+          <a:lstStyle/>
+          <a:p>
+            <a:pPr algn="l"/>
+            <a:r>
+              <a:rPr sz="1000" b="1" i="0">
+                <a:solidFill>
+                  <a:srgbClr val="003087"/>
+                </a:solidFill>
+                <a:latin typeface="Segoe UI"/>
+              </a:rPr>
+              <a:t>❌  RR</a:t>
+            </a:r>
+          </a:p>
+        </p:txBody>
+      </p:sp>
+      <p:sp>
+        <p:nvSpPr>
+          <p:cNvPr id="35" name="TextBox 34"/>
+          <p:cNvSpPr txBox="1"/>
+          <p:nvPr/>
+        </p:nvSpPr>
+        <p:spPr>
+          <a:xfrm>
+            <a:off x="2606040" y="4242816"/>
+            <a:ext cx="8961120" cy="237744"/>
+          </a:xfrm>
+          <a:prstGeom prst="rect">
+            <a:avLst/>
+          </a:prstGeom>
+          <a:noFill/>
+        </p:spPr>
+        <p:txBody>
+          <a:bodyPr wrap="square">
+            <a:spAutoFit/>
+          </a:bodyPr>
+          <a:lstStyle/>
+          <a:p>
+            <a:pPr algn="l"/>
+            <a:r>
+              <a:rPr sz="1000" b="0" i="0">
+                <a:solidFill>
+                  <a:srgbClr val="555555"/>
+                </a:solidFill>
+                <a:latin typeface="Segoe UI"/>
+              </a:rPr>
+              <a:t>Refus de Répondre — raccroché / agressif — idem 4 mois</a:t>
+            </a:r>
+          </a:p>
+        </p:txBody>
+      </p:sp>
+      <p:sp>
+        <p:nvSpPr>
+          <p:cNvPr id="36" name="Rectangle 35"/>
+          <p:cNvSpPr/>
+          <p:nvPr/>
+        </p:nvSpPr>
+        <p:spPr>
+          <a:xfrm>
+            <a:off x="320040" y="4626864"/>
+            <a:ext cx="11521440" cy="438912"/>
+          </a:xfrm>
+          <a:prstGeom prst="rect">
+            <a:avLst/>
+          </a:prstGeom>
+          <a:solidFill>
+            <a:srgbClr val="F7941D"/>
+          </a:solidFill>
+          <a:ln>
+            <a:noFill/>
+          </a:ln>
+        </p:spPr>
+        <p:style>
+          <a:lnRef idx="1">
+            <a:schemeClr val="accent1"/>
+          </a:lnRef>
+          <a:fillRef idx="3">
+            <a:schemeClr val="accent1"/>
+          </a:fillRef>
+          <a:effectRef idx="2">
+            <a:schemeClr val="accent1"/>
+          </a:effectRef>
+          <a:fontRef idx="minor">
+            <a:schemeClr val="lt1"/>
+          </a:fontRef>
+        </p:style>
+        <p:txBody>
+          <a:bodyPr rtlCol="0" anchor="ctr"/>
+          <a:lstStyle/>
+          <a:p>
+            <a:pPr algn="ctr"/>
+          </a:p>
+        </p:txBody>
+      </p:sp>
+      <p:sp>
+        <p:nvSpPr>
+          <p:cNvPr id="37" name="TextBox 36"/>
+          <p:cNvSpPr txBox="1"/>
+          <p:nvPr/>
+        </p:nvSpPr>
+        <p:spPr>
+          <a:xfrm>
+            <a:off x="502920" y="4681728"/>
+            <a:ext cx="10972800" cy="329184"/>
+          </a:xfrm>
+          <a:prstGeom prst="rect">
+            <a:avLst/>
+          </a:prstGeom>
+          <a:noFill/>
+        </p:spPr>
+        <p:txBody>
+          <a:bodyPr wrap="square">
+            <a:spAutoFit/>
+          </a:bodyPr>
+          <a:lstStyle/>
+          <a:p>
+            <a:pPr algn="l"/>
+            <a:r>
+              <a:rPr sz="1000" b="1" i="0">
+                <a:solidFill>
+                  <a:srgbClr val="FFFFFF"/>
+                </a:solidFill>
+                <a:latin typeface="Segoe UI"/>
+              </a:rPr>
+              <a:t>EXEMPLE ERREUR : Répondeur → qualifié RA (FAUX) — le bon code est ABSENT. La personne n'a pas refusé, elle était absente.</a:t>
+            </a:r>
+          </a:p>
+        </p:txBody>
+      </p:sp>
+      <p:sp>
+        <p:nvSpPr>
+          <p:cNvPr id="38" name="Rectangle 37"/>
+          <p:cNvSpPr/>
+          <p:nvPr/>
+        </p:nvSpPr>
+        <p:spPr>
+          <a:xfrm>
+            <a:off x="320040" y="5212080"/>
+            <a:ext cx="11521440" cy="347472"/>
+          </a:xfrm>
+          <a:prstGeom prst="rect">
+            <a:avLst/>
+          </a:prstGeom>
+          <a:solidFill>
+            <a:srgbClr val="E8F0FB"/>
+          </a:solidFill>
+          <a:ln w="10160">
+            <a:solidFill>
+              <a:srgbClr val="0D9488"/>
+            </a:solidFill>
+          </a:ln>
+        </p:spPr>
+        <p:style>
+          <a:lnRef idx="1">
+            <a:schemeClr val="accent1"/>
+          </a:lnRef>
+          <a:fillRef idx="3">
+            <a:schemeClr val="accent1"/>
+          </a:fillRef>
+          <a:effectRef idx="2">
+            <a:schemeClr val="accent1"/>
+          </a:effectRef>
+          <a:fontRef idx="minor">
+            <a:schemeClr val="lt1"/>
+          </a:fontRef>
+        </p:style>
+        <p:txBody>
+          <a:bodyPr rtlCol="0" anchor="ctr"/>
+          <a:lstStyle/>
+          <a:p>
+            <a:pPr algn="ctr"/>
+          </a:p>
+        </p:txBody>
+      </p:sp>
+      <p:sp>
+        <p:nvSpPr>
+          <p:cNvPr id="39" name="Rectangle 38"/>
+          <p:cNvSpPr/>
+          <p:nvPr/>
+        </p:nvSpPr>
+        <p:spPr>
+          <a:xfrm>
+            <a:off x="320040" y="5212080"/>
+            <a:ext cx="54864" cy="347472"/>
+          </a:xfrm>
+          <a:prstGeom prst="rect">
+            <a:avLst/>
+          </a:prstGeom>
+          <a:solidFill>
+            <a:srgbClr val="0D9488"/>
+          </a:solidFill>
+          <a:ln>
+            <a:noFill/>
+          </a:ln>
+        </p:spPr>
+        <p:style>
+          <a:lnRef idx="1">
+            <a:schemeClr val="accent1"/>
+          </a:lnRef>
+          <a:fillRef idx="3">
+            <a:schemeClr val="accent1"/>
+          </a:fillRef>
+          <a:effectRef idx="2">
+            <a:schemeClr val="accent1"/>
+          </a:effectRef>
+          <a:fontRef idx="minor">
+            <a:schemeClr val="lt1"/>
+          </a:fontRef>
+        </p:style>
+        <p:txBody>
+          <a:bodyPr rtlCol="0" anchor="ctr"/>
+          <a:lstStyle/>
+          <a:p>
+            <a:pPr algn="ctr"/>
+          </a:p>
+        </p:txBody>
+      </p:sp>
+      <p:sp>
+        <p:nvSpPr>
+          <p:cNvPr id="40" name="TextBox 39"/>
+          <p:cNvSpPr txBox="1"/>
+          <p:nvPr/>
+        </p:nvSpPr>
+        <p:spPr>
+          <a:xfrm>
+            <a:off x="502920" y="5266944"/>
+            <a:ext cx="2286000" cy="237744"/>
+          </a:xfrm>
+          <a:prstGeom prst="rect">
+            <a:avLst/>
+          </a:prstGeom>
+          <a:noFill/>
+        </p:spPr>
+        <p:txBody>
+          <a:bodyPr wrap="square">
+            <a:spAutoFit/>
+          </a:bodyPr>
+          <a:lstStyle/>
+          <a:p>
+            <a:pPr algn="l"/>
+            <a:r>
+              <a:rPr sz="1000" b="1" i="0">
+                <a:solidFill>
+                  <a:srgbClr val="0D9488"/>
+                </a:solidFill>
+                <a:latin typeface="Segoe UI"/>
+              </a:rPr>
+              <a:t>ABSENT</a:t>
+            </a:r>
+          </a:p>
+        </p:txBody>
+      </p:sp>
+      <p:sp>
+        <p:nvSpPr>
+          <p:cNvPr id="41" name="TextBox 40"/>
+          <p:cNvSpPr txBox="1"/>
+          <p:nvPr/>
+        </p:nvSpPr>
+        <p:spPr>
+          <a:xfrm>
+            <a:off x="2834640" y="5266944"/>
+            <a:ext cx="8778240" cy="237744"/>
+          </a:xfrm>
+          <a:prstGeom prst="rect">
+            <a:avLst/>
+          </a:prstGeom>
+          <a:noFill/>
+        </p:spPr>
+        <p:txBody>
+          <a:bodyPr wrap="square">
+            <a:spAutoFit/>
+          </a:bodyPr>
+          <a:lstStyle/>
+          <a:p>
+            <a:pPr algn="l"/>
+            <a:r>
+              <a:rPr sz="1000" b="0" i="0">
+                <a:solidFill>
+                  <a:srgbClr val="555555"/>
+                </a:solidFill>
+                <a:latin typeface="Segoe UI"/>
+              </a:rPr>
+              <a:t>Répondeur, NRP, raccroché sans ID — recontacter, pas un refus</a:t>
+            </a:r>
+          </a:p>
+        </p:txBody>
+      </p:sp>
+      <p:sp>
+        <p:nvSpPr>
+          <p:cNvPr id="42" name="Rectangle 41"/>
+          <p:cNvSpPr/>
+          <p:nvPr/>
+        </p:nvSpPr>
+        <p:spPr>
+          <a:xfrm>
+            <a:off x="320040" y="5577840"/>
+            <a:ext cx="11521440" cy="347472"/>
+          </a:xfrm>
+          <a:prstGeom prst="rect">
+            <a:avLst/>
+          </a:prstGeom>
+          <a:solidFill>
+            <a:srgbClr val="E8F0FB"/>
+          </a:solidFill>
+          <a:ln w="10160">
+            <a:solidFill>
+              <a:srgbClr val="E74C3C"/>
+            </a:solidFill>
+          </a:ln>
+        </p:spPr>
+        <p:style>
+          <a:lnRef idx="1">
+            <a:schemeClr val="accent1"/>
+          </a:lnRef>
+          <a:fillRef idx="3">
+            <a:schemeClr val="accent1"/>
+          </a:fillRef>
+          <a:effectRef idx="2">
+            <a:schemeClr val="accent1"/>
+          </a:effectRef>
+          <a:fontRef idx="minor">
+            <a:schemeClr val="lt1"/>
+          </a:fontRef>
+        </p:style>
+        <p:txBody>
+          <a:bodyPr rtlCol="0" anchor="ctr"/>
+          <a:lstStyle/>
+          <a:p>
+            <a:pPr algn="ctr"/>
+          </a:p>
+        </p:txBody>
+      </p:sp>
+      <p:sp>
+        <p:nvSpPr>
+          <p:cNvPr id="43" name="Rectangle 42"/>
+          <p:cNvSpPr/>
+          <p:nvPr/>
+        </p:nvSpPr>
+        <p:spPr>
+          <a:xfrm>
+            <a:off x="320040" y="5577840"/>
+            <a:ext cx="54864" cy="347472"/>
+          </a:xfrm>
+          <a:prstGeom prst="rect">
+            <a:avLst/>
+          </a:prstGeom>
+          <a:solidFill>
+            <a:srgbClr val="E74C3C"/>
+          </a:solidFill>
+          <a:ln>
+            <a:noFill/>
+          </a:ln>
+        </p:spPr>
+        <p:style>
+          <a:lnRef idx="1">
+            <a:schemeClr val="accent1"/>
+          </a:lnRef>
+          <a:fillRef idx="3">
+            <a:schemeClr val="accent1"/>
+          </a:fillRef>
+          <a:effectRef idx="2">
+            <a:schemeClr val="accent1"/>
+          </a:effectRef>
+          <a:fontRef idx="minor">
+            <a:schemeClr val="lt1"/>
+          </a:fontRef>
+        </p:style>
+        <p:txBody>
+          <a:bodyPr rtlCol="0" anchor="ctr"/>
+          <a:lstStyle/>
+          <a:p>
+            <a:pPr algn="ctr"/>
+          </a:p>
+        </p:txBody>
+      </p:sp>
+      <p:sp>
+        <p:nvSpPr>
+          <p:cNvPr id="44" name="TextBox 43"/>
+          <p:cNvSpPr txBox="1"/>
+          <p:nvPr/>
+        </p:nvSpPr>
+        <p:spPr>
+          <a:xfrm>
+            <a:off x="502920" y="5632704"/>
+            <a:ext cx="2286000" cy="237744"/>
+          </a:xfrm>
+          <a:prstGeom prst="rect">
+            <a:avLst/>
+          </a:prstGeom>
+          <a:noFill/>
+        </p:spPr>
+        <p:txBody>
+          <a:bodyPr wrap="square">
+            <a:spAutoFit/>
+          </a:bodyPr>
+          <a:lstStyle/>
+          <a:p>
+            <a:pPr algn="l"/>
+            <a:r>
+              <a:rPr sz="1000" b="1" i="0">
+                <a:solidFill>
+                  <a:srgbClr val="E74C3C"/>
+                </a:solidFill>
+                <a:latin typeface="Segoe UI"/>
+              </a:rPr>
+              <a:t>CICR</a:t>
+            </a:r>
+          </a:p>
+        </p:txBody>
+      </p:sp>
+      <p:sp>
+        <p:nvSpPr>
+          <p:cNvPr id="45" name="TextBox 44"/>
+          <p:cNvSpPr txBox="1"/>
+          <p:nvPr/>
+        </p:nvSpPr>
+        <p:spPr>
+          <a:xfrm>
+            <a:off x="2834640" y="5632704"/>
+            <a:ext cx="8778240" cy="237744"/>
+          </a:xfrm>
+          <a:prstGeom prst="rect">
+            <a:avLst/>
+          </a:prstGeom>
+          <a:noFill/>
+        </p:spPr>
+        <p:txBody>
+          <a:bodyPr wrap="square">
+            <a:spAutoFit/>
+          </a:bodyPr>
+          <a:lstStyle/>
+          <a:p>
+            <a:pPr algn="l"/>
+            <a:r>
+              <a:rPr sz="1000" b="0" i="0">
+                <a:solidFill>
+                  <a:srgbClr val="555555"/>
+                </a:solidFill>
+                <a:latin typeface="Segoe UI"/>
+              </a:rPr>
+              <a:t>Croix-Rouge internationale — zones de conflit, échanges d'otages, prisonniers de guerre</a:t>
+            </a:r>
+          </a:p>
+        </p:txBody>
+      </p:sp>
+      <p:sp>
+        <p:nvSpPr>
+          <p:cNvPr id="46" name="Rectangle 45"/>
+          <p:cNvSpPr/>
+          <p:nvPr/>
+        </p:nvSpPr>
+        <p:spPr>
+          <a:xfrm>
+            <a:off x="320040" y="5943600"/>
+            <a:ext cx="11521440" cy="347472"/>
+          </a:xfrm>
+          <a:prstGeom prst="rect">
+            <a:avLst/>
+          </a:prstGeom>
+          <a:solidFill>
+            <a:srgbClr val="E8F0FB"/>
+          </a:solidFill>
+          <a:ln w="10160">
+            <a:solidFill>
+              <a:srgbClr val="0057B8"/>
+            </a:solidFill>
+          </a:ln>
+        </p:spPr>
+        <p:style>
+          <a:lnRef idx="1">
+            <a:schemeClr val="accent1"/>
+          </a:lnRef>
+          <a:fillRef idx="3">
+            <a:schemeClr val="accent1"/>
+          </a:fillRef>
+          <a:effectRef idx="2">
+            <a:schemeClr val="accent1"/>
+          </a:effectRef>
+          <a:fontRef idx="minor">
+            <a:schemeClr val="lt1"/>
+          </a:fontRef>
+        </p:style>
+        <p:txBody>
+          <a:bodyPr rtlCol="0" anchor="ctr"/>
+          <a:lstStyle/>
+          <a:p>
+            <a:pPr algn="ctr"/>
+          </a:p>
+        </p:txBody>
+      </p:sp>
+      <p:sp>
+        <p:nvSpPr>
+          <p:cNvPr id="47" name="Rectangle 46"/>
+          <p:cNvSpPr/>
+          <p:nvPr/>
+        </p:nvSpPr>
+        <p:spPr>
+          <a:xfrm>
+            <a:off x="320040" y="5943600"/>
+            <a:ext cx="54864" cy="347472"/>
+          </a:xfrm>
+          <a:prstGeom prst="rect">
+            <a:avLst/>
+          </a:prstGeom>
+          <a:solidFill>
+            <a:srgbClr val="0057B8"/>
+          </a:solidFill>
+          <a:ln>
+            <a:noFill/>
+          </a:ln>
+        </p:spPr>
+        <p:style>
+          <a:lnRef idx="1">
+            <a:schemeClr val="accent1"/>
+          </a:lnRef>
+          <a:fillRef idx="3">
+            <a:schemeClr val="accent1"/>
+          </a:fillRef>
+          <a:effectRef idx="2">
+            <a:schemeClr val="accent1"/>
+          </a:effectRef>
+          <a:fontRef idx="minor">
+            <a:schemeClr val="lt1"/>
+          </a:fontRef>
+        </p:style>
+        <p:txBody>
+          <a:bodyPr rtlCol="0" anchor="ctr"/>
+          <a:lstStyle/>
+          <a:p>
+            <a:pPr algn="ctr"/>
+          </a:p>
+        </p:txBody>
+      </p:sp>
+      <p:sp>
+        <p:nvSpPr>
+          <p:cNvPr id="48" name="TextBox 47"/>
+          <p:cNvSpPr txBox="1"/>
+          <p:nvPr/>
+        </p:nvSpPr>
+        <p:spPr>
+          <a:xfrm>
+            <a:off x="502920" y="5998464"/>
+            <a:ext cx="2286000" cy="237744"/>
+          </a:xfrm>
+          <a:prstGeom prst="rect">
+            <a:avLst/>
+          </a:prstGeom>
+          <a:noFill/>
+        </p:spPr>
+        <p:txBody>
+          <a:bodyPr wrap="square">
+            <a:spAutoFit/>
+          </a:bodyPr>
+          <a:lstStyle/>
+          <a:p>
+            <a:pPr algn="l"/>
+            <a:r>
+              <a:rPr sz="1000" b="1" i="0">
+                <a:solidFill>
+                  <a:srgbClr val="0057B8"/>
+                </a:solidFill>
+                <a:latin typeface="Segoe UI"/>
+              </a:rPr>
+              <a:t>COMITÉ DE LA CHARTE</a:t>
+            </a:r>
+          </a:p>
+        </p:txBody>
+      </p:sp>
+      <p:sp>
+        <p:nvSpPr>
+          <p:cNvPr id="49" name="TextBox 48"/>
+          <p:cNvSpPr txBox="1"/>
+          <p:nvPr/>
+        </p:nvSpPr>
+        <p:spPr>
+          <a:xfrm>
+            <a:off x="2834640" y="5998464"/>
+            <a:ext cx="8778240" cy="237744"/>
+          </a:xfrm>
+          <a:prstGeom prst="rect">
+            <a:avLst/>
+          </a:prstGeom>
+          <a:noFill/>
+        </p:spPr>
+        <p:txBody>
+          <a:bodyPr wrap="square">
+            <a:spAutoFit/>
+          </a:bodyPr>
+          <a:lstStyle/>
+          <a:p>
+            <a:pPr algn="l"/>
+            <a:r>
+              <a:rPr sz="1000" b="0" i="0">
+                <a:solidFill>
+                  <a:srgbClr val="555555"/>
+                </a:solidFill>
+                <a:latin typeface="Segoe UI"/>
+              </a:rPr>
+              <a:t>Créé 1989, renforcé 1996 — audits, label Don en Confiance, contrôle État</a:t>
+            </a:r>
+          </a:p>
+        </p:txBody>
+      </p:sp>
+      <p:sp>
+        <p:nvSpPr>
+          <p:cNvPr id="50" name="Rectangle 49"/>
+          <p:cNvSpPr/>
+          <p:nvPr/>
+        </p:nvSpPr>
+        <p:spPr>
+          <a:xfrm>
+            <a:off x="320040" y="6309360"/>
+            <a:ext cx="11521440" cy="347472"/>
+          </a:xfrm>
+          <a:prstGeom prst="rect">
+            <a:avLst/>
+          </a:prstGeom>
+          <a:solidFill>
+            <a:srgbClr val="E8F0FB"/>
+          </a:solidFill>
+          <a:ln w="10160">
+            <a:solidFill>
+              <a:srgbClr val="F7941D"/>
+            </a:solidFill>
+          </a:ln>
+        </p:spPr>
+        <p:style>
+          <a:lnRef idx="1">
+            <a:schemeClr val="accent1"/>
+          </a:lnRef>
+          <a:fillRef idx="3">
+            <a:schemeClr val="accent1"/>
+          </a:fillRef>
+          <a:effectRef idx="2">
+            <a:schemeClr val="accent1"/>
+          </a:effectRef>
+          <a:fontRef idx="minor">
+            <a:schemeClr val="lt1"/>
+          </a:fontRef>
+        </p:style>
+        <p:txBody>
+          <a:bodyPr rtlCol="0" anchor="ctr"/>
+          <a:lstStyle/>
+          <a:p>
+            <a:pPr algn="ctr"/>
+          </a:p>
+        </p:txBody>
+      </p:sp>
+      <p:sp>
+        <p:nvSpPr>
+          <p:cNvPr id="51" name="Rectangle 50"/>
+          <p:cNvSpPr/>
+          <p:nvPr/>
+        </p:nvSpPr>
+        <p:spPr>
+          <a:xfrm>
+            <a:off x="320040" y="6309360"/>
+            <a:ext cx="54864" cy="347472"/>
+          </a:xfrm>
+          <a:prstGeom prst="rect">
+            <a:avLst/>
+          </a:prstGeom>
+          <a:solidFill>
+            <a:srgbClr val="F7941D"/>
+          </a:solidFill>
+          <a:ln>
+            <a:noFill/>
+          </a:ln>
+        </p:spPr>
+        <p:style>
+          <a:lnRef idx="1">
+            <a:schemeClr val="accent1"/>
+          </a:lnRef>
+          <a:fillRef idx="3">
+            <a:schemeClr val="accent1"/>
+          </a:fillRef>
+          <a:effectRef idx="2">
+            <a:schemeClr val="accent1"/>
+          </a:effectRef>
+          <a:fontRef idx="minor">
+            <a:schemeClr val="lt1"/>
+          </a:fontRef>
+        </p:style>
+        <p:txBody>
+          <a:bodyPr rtlCol="0" anchor="ctr"/>
+          <a:lstStyle/>
+          <a:p>
+            <a:pPr algn="ctr"/>
+          </a:p>
+        </p:txBody>
+      </p:sp>
+      <p:sp>
+        <p:nvSpPr>
+          <p:cNvPr id="52" name="TextBox 51"/>
+          <p:cNvSpPr txBox="1"/>
+          <p:nvPr/>
+        </p:nvSpPr>
+        <p:spPr>
+          <a:xfrm>
+            <a:off x="502920" y="6364224"/>
+            <a:ext cx="2286000" cy="237744"/>
+          </a:xfrm>
+          <a:prstGeom prst="rect">
+            <a:avLst/>
+          </a:prstGeom>
+          <a:noFill/>
+        </p:spPr>
+        <p:txBody>
+          <a:bodyPr wrap="square">
+            <a:spAutoFit/>
+          </a:bodyPr>
+          <a:lstStyle/>
+          <a:p>
+            <a:pPr algn="l"/>
+            <a:r>
+              <a:rPr sz="1000" b="1" i="0">
+                <a:solidFill>
+                  <a:srgbClr val="F7941D"/>
+                </a:solidFill>
+                <a:latin typeface="Segoe UI"/>
+              </a:rPr>
+              <a:t>PARTICULIER / PRO</a:t>
+            </a:r>
+          </a:p>
+        </p:txBody>
+      </p:sp>
+      <p:sp>
+        <p:nvSpPr>
+          <p:cNvPr id="53" name="TextBox 52"/>
+          <p:cNvSpPr txBox="1"/>
+          <p:nvPr/>
+        </p:nvSpPr>
+        <p:spPr>
+          <a:xfrm>
+            <a:off x="2834640" y="6364224"/>
+            <a:ext cx="8778240" cy="237744"/>
+          </a:xfrm>
+          <a:prstGeom prst="rect">
+            <a:avLst/>
+          </a:prstGeom>
+          <a:noFill/>
+        </p:spPr>
+        <p:txBody>
+          <a:bodyPr wrap="square">
+            <a:spAutoFit/>
+          </a:bodyPr>
+          <a:lstStyle/>
+          <a:p>
+            <a:pPr algn="l"/>
+            <a:r>
+              <a:rPr sz="1000" b="0" i="0">
+                <a:solidFill>
+                  <a:srgbClr val="555555"/>
+                </a:solidFill>
+                <a:latin typeface="Segoe UI"/>
+              </a:rPr>
+              <a:t>Dons = particuliers uniquement. Pro atteint → ABSENT ou demander numéro perso</a:t>
+            </a:r>
+          </a:p>
+        </p:txBody>
+      </p:sp>
+      <p:sp>
+        <p:nvSpPr>
+          <p:cNvPr id="54" name="Rectangle 53"/>
+          <p:cNvSpPr/>
+          <p:nvPr/>
+        </p:nvSpPr>
+        <p:spPr>
+          <a:xfrm>
+            <a:off x="320040" y="6675120"/>
+            <a:ext cx="11521440" cy="347472"/>
+          </a:xfrm>
+          <a:prstGeom prst="rect">
+            <a:avLst/>
+          </a:prstGeom>
+          <a:solidFill>
+            <a:srgbClr val="E8F0FB"/>
+          </a:solidFill>
+          <a:ln w="10160">
+            <a:solidFill>
+              <a:srgbClr val="7C3AED"/>
+            </a:solidFill>
+          </a:ln>
+        </p:spPr>
+        <p:style>
+          <a:lnRef idx="1">
+            <a:schemeClr val="accent1"/>
+          </a:lnRef>
+          <a:fillRef idx="3">
+            <a:schemeClr val="accent1"/>
+          </a:fillRef>
+          <a:effectRef idx="2">
+            <a:schemeClr val="accent1"/>
+          </a:effectRef>
+          <a:fontRef idx="minor">
+            <a:schemeClr val="lt1"/>
+          </a:fontRef>
+        </p:style>
+        <p:txBody>
+          <a:bodyPr rtlCol="0" anchor="ctr"/>
+          <a:lstStyle/>
+          <a:p>
+            <a:pPr algn="ctr"/>
+          </a:p>
+        </p:txBody>
+      </p:sp>
+      <p:sp>
+        <p:nvSpPr>
+          <p:cNvPr id="55" name="Rectangle 54"/>
+          <p:cNvSpPr/>
+          <p:nvPr/>
+        </p:nvSpPr>
+        <p:spPr>
+          <a:xfrm>
+            <a:off x="320040" y="6675120"/>
+            <a:ext cx="54864" cy="347472"/>
+          </a:xfrm>
+          <a:prstGeom prst="rect">
+            <a:avLst/>
+          </a:prstGeom>
+          <a:solidFill>
+            <a:srgbClr val="7C3AED"/>
+          </a:solidFill>
+          <a:ln>
+            <a:noFill/>
+          </a:ln>
+        </p:spPr>
+        <p:style>
+          <a:lnRef idx="1">
+            <a:schemeClr val="accent1"/>
+          </a:lnRef>
+          <a:fillRef idx="3">
+            <a:schemeClr val="accent1"/>
+          </a:fillRef>
+          <a:effectRef idx="2">
+            <a:schemeClr val="accent1"/>
+          </a:effectRef>
+          <a:fontRef idx="minor">
+            <a:schemeClr val="lt1"/>
+          </a:fontRef>
+        </p:style>
+        <p:txBody>
+          <a:bodyPr rtlCol="0" anchor="ctr"/>
+          <a:lstStyle/>
+          <a:p>
+            <a:pPr algn="ctr"/>
+          </a:p>
+        </p:txBody>
+      </p:sp>
+      <p:sp>
+        <p:nvSpPr>
+          <p:cNvPr id="56" name="TextBox 55"/>
+          <p:cNvSpPr txBox="1"/>
+          <p:nvPr/>
+        </p:nvSpPr>
+        <p:spPr>
+          <a:xfrm>
+            <a:off x="502920" y="6729984"/>
+            <a:ext cx="2286000" cy="237744"/>
+          </a:xfrm>
+          <a:prstGeom prst="rect">
+            <a:avLst/>
+          </a:prstGeom>
+          <a:noFill/>
+        </p:spPr>
+        <p:txBody>
+          <a:bodyPr wrap="square">
+            <a:spAutoFit/>
+          </a:bodyPr>
+          <a:lstStyle/>
+          <a:p>
+            <a:pPr algn="l"/>
+            <a:r>
+              <a:rPr sz="1000" b="1" i="0">
+                <a:solidFill>
+                  <a:srgbClr val="7C3AED"/>
+                </a:solidFill>
+                <a:latin typeface="Segoe UI"/>
+              </a:rPr>
+              <a:t>FIDELIS = RUP</a:t>
+            </a:r>
+          </a:p>
+        </p:txBody>
+      </p:sp>
+      <p:sp>
+        <p:nvSpPr>
+          <p:cNvPr id="57" name="TextBox 56"/>
+          <p:cNvSpPr txBox="1"/>
+          <p:nvPr/>
+        </p:nvSpPr>
+        <p:spPr>
+          <a:xfrm>
+            <a:off x="2834640" y="6729984"/>
+            <a:ext cx="8778240" cy="237744"/>
+          </a:xfrm>
+          <a:prstGeom prst="rect">
+            <a:avLst/>
+          </a:prstGeom>
+          <a:noFill/>
+        </p:spPr>
+        <p:txBody>
+          <a:bodyPr wrap="square">
+            <a:spAutoFit/>
+          </a:bodyPr>
+          <a:lstStyle/>
+          <a:p>
+            <a:pPr algn="l"/>
+            <a:r>
+              <a:rPr sz="1000" b="0" i="0">
+                <a:solidFill>
+                  <a:srgbClr val="555555"/>
+                </a:solidFill>
+                <a:latin typeface="Segoe UI"/>
+              </a:rPr>
+              <a:t>Fidelis travaille EXCLUSIVEMENT avec associations Reconnues d'Utilité Publique</a:t>
             </a:r>
           </a:p>
         </p:txBody>

</xml_diff>

<commit_message>
Update J2 book (18 slides) and synthesis — corrections + new content
Corrections:
- Remove MATINÉE/APRÈS-MIDI from all titles, footers, module name
- Remove programme prévu demain (recap slide)
- Solférino slide: grey background instead of black
- Particuliers/Pro: demander l'IBAN PERSONNEL (not numéro personnel)
- Remove Ne qualifiez PAS phrase from slides 13 and 15

New slides added:
- Slide 16: Les Outils de Collecte (définition, formes, causes, facteurs du don)
- Slide 17: Le Marketing Téléphonique (5 avantages + comparatif canaux)
- Slide 18: Questionnaire officiel 10 questions MCQ avec réponses

https://claude.ai/code/session_017qsYoeojf57UYvTwdv5u93
</commit_message>
<xml_diff>
--- a/Synthese_J2_Matin_Fidelis.pptx
+++ b/Synthese_J2_Matin_Fidelis.pptx
@@ -3299,7 +3299,7 @@
                 </a:solidFill>
                 <a:latin typeface="Segoe UI"/>
               </a:rPr>
-              <a:t>RÉVEIL PÉDAGOGIQUE  ·  PRÉ-SESSION J2 APRÈS-MIDI</a:t>
+              <a:t>RÉVEIL PÉDAGOGIQUE  ·  PRÉ-SESSION J2</a:t>
             </a:r>
           </a:p>
         </p:txBody>
@@ -3340,13 +3340,13 @@
           <a:p>
             <a:pPr algn="l"/>
             <a:r>
-              <a:rPr sz="2400" b="0" i="0">
+              <a:rPr sz="2800" b="0" i="0">
                 <a:solidFill>
                   <a:srgbClr val="00AEEF"/>
                 </a:solidFill>
                 <a:latin typeface="Segoe UI"/>
               </a:rPr>
-              <a:t>MODULE J2 — MATINÉE</a:t>
+              <a:t>MODULE J2</a:t>
             </a:r>
           </a:p>
           <a:p>
@@ -3397,7 +3397,7 @@
                 </a:solidFill>
                 <a:latin typeface="Segoe UI"/>
               </a:rPr>
-              <a:t>Rappel des axes clés de la matinée avant de
+              <a:t>Rappel des axes clés du J2 avant de
 démarrer la suite du programme.</a:t>
             </a:r>
           </a:p>
@@ -6437,7 +6437,7 @@
                 </a:solidFill>
                 <a:latin typeface="Segoe UI"/>
               </a:rPr>
-              <a:t>Dons = particuliers uniquement. Pro atteint → ABSENT ou demander numéro perso</a:t>
+              <a:t>Dons = particuliers uniquement. Pro atteint → demander l'IBAN PERSONNEL pour un don de son compte personnel</a:t>
             </a:r>
           </a:p>
         </p:txBody>
@@ -16640,7 +16640,7 @@
                 </a:solidFill>
                 <a:latin typeface="Segoe UI"/>
               </a:rPr>
-              <a:t>Testez vos connaissances avant de démarrer l'après-midi</a:t>
+              <a:t>Testez vos connaissances — 6 questions clés</a:t>
             </a:r>
           </a:p>
         </p:txBody>
@@ -18358,7 +18358,7 @@
                 </a:solidFill>
                 <a:latin typeface="Segoe UI"/>
               </a:rPr>
-              <a:t>À retenir de la matinée J2</a:t>
+              <a:t>À retenir du Module J2</a:t>
             </a:r>
           </a:p>
         </p:txBody>
@@ -19609,7 +19609,7 @@
                 </a:solidFill>
                 <a:latin typeface="Segoe UI"/>
               </a:rPr>
-              <a:t>MANTRA J2 MATINÉE</a:t>
+              <a:t>MANTRA J2</a:t>
             </a:r>
           </a:p>
         </p:txBody>
@@ -19664,7 +19664,7 @@
             <a:avLst/>
           </a:prstGeom>
           <a:solidFill>
-            <a:srgbClr val="0A1F3A"/>
+            <a:srgbClr val="003087"/>
           </a:solidFill>
           <a:ln>
             <a:noFill/>
@@ -19722,7 +19722,7 @@
                 </a:solidFill>
                 <a:latin typeface="Segoe UI"/>
               </a:rPr>
-              <a:t>PROCHAINE ÉTAPE — APRÈS-MIDI J2</a:t>
+              <a:t>LES OUTILS DE COLLECTE — À RETENIR</a:t>
             </a:r>
           </a:p>
         </p:txBody>
@@ -19757,7 +19757,7 @@
                 </a:solidFill>
                 <a:latin typeface="Segoe UI"/>
               </a:rPr>
-              <a:t>Traitement des objections  •  Discours de conviction  •  Simulations téléphoniques  •  Plan d'action personnel</a:t>
+              <a:t>Collecte de dons = IBAN préféré  •  65 ans+ = 60 % de donateurs réguliers  •  Phoning = 55 % du marché  •  Fundraising = Collecte de fonds</a:t>
             </a:r>
           </a:p>
         </p:txBody>

</xml_diff>